<commit_message>
docs: add team members (Najimdeen Adam Oyeyemi & Olagunju Temitope) and enterprise tech stack across all submission files and pitch decks
</commit_message>
<xml_diff>
--- a/submission/SANAD_Executive_Presentation_Deck_Warba_Bank.pptx
+++ b/submission/SANAD_Executive_Presentation_Deck_Warba_Bank.pptx
@@ -17,6 +17,7 @@
     <p:sldId id="265" r:id="rId16"/>
     <p:sldId id="266" r:id="rId17"/>
     <p:sldId id="267" r:id="rId18"/>
+    <p:sldId id="268" r:id="rId19"/>
   </p:sldIdLst>
   <p:sldSz cx="12191695" cy="6858000" type="screen4x3"/>
   <p:notesSz cx="6858000" cy="9144000"/>
@@ -3234,8 +3235,8 @@
         </p:nvSpPr>
         <p:spPr>
           <a:xfrm>
-            <a:off x="914400" y="4663440"/>
-            <a:ext cx="10332720" cy="1371600"/>
+            <a:off x="914400" y="4480560"/>
+            <a:ext cx="10332720" cy="1737360"/>
           </a:xfrm>
           <a:prstGeom prst="roundRect">
             <a:avLst/>
@@ -3279,8 +3280,8 @@
         </p:nvSpPr>
         <p:spPr>
           <a:xfrm>
-            <a:off x="1097280" y="4754880"/>
-            <a:ext cx="9966960" cy="1188720"/>
+            <a:off x="1097280" y="4572000"/>
+            <a:ext cx="9966960" cy="1554480"/>
           </a:xfrm>
           <a:prstGeom prst="rect">
             <a:avLst/>
@@ -3296,29 +3297,55 @@
             <a:pPr>
               <a:defRPr sz="1300" b="1">
                 <a:solidFill>
+                  <a:srgbClr val="10B981"/>
+                </a:solidFill>
+              </a:defRPr>
+            </a:pPr>
+            <a:r>
+              <a:t>👥 Core Team: Najimdeen Adam Oyeyemi &amp; Olagunju Temitope</a:t>
+            </a:r>
+          </a:p>
+          <a:p>
+            <a:pPr>
+              <a:spcBef>
+                <a:spcPts val="300"/>
+              </a:spcBef>
+              <a:defRPr sz="1100" b="1">
+                <a:solidFill>
                   <a:srgbClr val="FFFFFF"/>
                 </a:solidFill>
               </a:defRPr>
             </a:pPr>
             <a:r>
-              <a:t>🌐 Live Production Web App: https://sanad-engine.netlify.app</a:t>
-            </a:r>
-          </a:p>
-          <a:p>
-            <a:pPr>
-              <a:spcBef>
-                <a:spcPts val="400"/>
-              </a:spcBef>
-              <a:defRPr sz="1050">
+              <a:t>💻 Stack: React 19, TypeScript, Vite, Python (FastAPI), Google Gemini 2.5, Docker, Railway, Netlify</a:t>
+            </a:r>
+          </a:p>
+          <a:p>
+            <a:pPr>
+              <a:spcBef>
+                <a:spcPts val="300"/>
+              </a:spcBef>
+              <a:defRPr sz="1050" b="1">
+                <a:solidFill>
+                  <a:srgbClr val="3B82F6"/>
+                </a:solidFill>
+              </a:defRPr>
+            </a:pPr>
+            <a:r>
+              <a:t>🌐 Live Production Web App: https://sanad-engine.netlify.app | ⚡ Backend API: https://sanad-production-9d51.up.railway.app/health</a:t>
+            </a:r>
+          </a:p>
+          <a:p>
+            <a:pPr>
+              <a:spcBef>
+                <a:spcPts val="300"/>
+              </a:spcBef>
+              <a:defRPr sz="1000">
                 <a:solidFill>
                   <a:srgbClr val="94A3B8"/>
                 </a:solidFill>
               </a:defRPr>
             </a:pPr>
-            <a:r>
-              <a:t>⚡ High-Availability Backend API: https://sanad-production-9d51.up.railway.app/health</a:t>
-            </a:r>
-            <a:br/>
             <a:r>
               <a:t>📂 Public GitHub Repository: https://github.com/anajimdeen01-debug/sanad-frontend</a:t>
             </a:r>
@@ -4462,7 +4489,7 @@
               </a:defRPr>
             </a:pPr>
             <a:r>
-              <a:t>Production Readiness: Live Demo &amp; 60-Second Evaluation Protocol</a:t>
+              <a:t>Core Engineering Team &amp; Production Technology Stack</a:t>
             </a:r>
           </a:p>
         </p:txBody>
@@ -4476,7 +4503,7 @@
         <p:spPr>
           <a:xfrm>
             <a:off x="731520" y="1645920"/>
-            <a:ext cx="10607040" cy="4389120"/>
+            <a:ext cx="5120640" cy="4389120"/>
           </a:xfrm>
           <a:prstGeom prst="roundRect">
             <a:avLst/>
@@ -4521,7 +4548,7 @@
         <p:spPr>
           <a:xfrm>
             <a:off x="914400" y="1783080"/>
-            <a:ext cx="10241280" cy="4114800"/>
+            <a:ext cx="4754880" cy="4114800"/>
           </a:xfrm>
           <a:prstGeom prst="rect">
             <a:avLst/>
@@ -4542,6 +4569,546 @@
               </a:defRPr>
             </a:pPr>
             <a:r>
+              <a:t>Engineering Team Leadership</a:t>
+            </a:r>
+          </a:p>
+          <a:p>
+            <a:pPr>
+              <a:defRPr sz="1000" b="1">
+                <a:solidFill>
+                  <a:srgbClr val="10B981"/>
+                </a:solidFill>
+              </a:defRPr>
+            </a:pPr>
+            <a:r>
+              <a:t>Founding Team</a:t>
+            </a:r>
+          </a:p>
+          <a:p>
+            <a:pPr>
+              <a:spcBef>
+                <a:spcPts val="500"/>
+              </a:spcBef>
+              <a:defRPr sz="1150">
+                <a:solidFill>
+                  <a:srgbClr val="CBD5E1"/>
+                </a:solidFill>
+              </a:defRPr>
+            </a:pPr>
+            <a:r>
+              <a:t>•  Najimdeen Adam Oyeyemi</a:t>
+            </a:r>
+          </a:p>
+          <a:p>
+            <a:pPr>
+              <a:spcBef>
+                <a:spcPts val="500"/>
+              </a:spcBef>
+              <a:defRPr sz="1150">
+                <a:solidFill>
+                  <a:srgbClr val="CBD5E1"/>
+                </a:solidFill>
+              </a:defRPr>
+            </a:pPr>
+            <a:r>
+              <a:t>•  Role: Lead AI &amp; Financial Systems Architect</a:t>
+            </a:r>
+          </a:p>
+          <a:p>
+            <a:pPr>
+              <a:spcBef>
+                <a:spcPts val="500"/>
+              </a:spcBef>
+              <a:defRPr sz="1150">
+                <a:solidFill>
+                  <a:srgbClr val="CBD5E1"/>
+                </a:solidFill>
+              </a:defRPr>
+            </a:pPr>
+            <a:r>
+              <a:t>•  Engineered: Google Gemini 2.5 autonomous multi-doc analysis pipelines, adversarial circularization engine, and AAOIFI deterministic Shariah accounting modules.</a:t>
+            </a:r>
+          </a:p>
+          <a:p>
+            <a:pPr>
+              <a:spcBef>
+                <a:spcPts val="500"/>
+              </a:spcBef>
+              <a:defRPr sz="1150">
+                <a:solidFill>
+                  <a:srgbClr val="CBD5E1"/>
+                </a:solidFill>
+              </a:defRPr>
+            </a:pPr>
+            <a:r>
+              <a:t>•   </a:t>
+            </a:r>
+          </a:p>
+          <a:p>
+            <a:pPr>
+              <a:spcBef>
+                <a:spcPts val="500"/>
+              </a:spcBef>
+              <a:defRPr sz="1150">
+                <a:solidFill>
+                  <a:srgbClr val="CBD5E1"/>
+                </a:solidFill>
+              </a:defRPr>
+            </a:pPr>
+            <a:r>
+              <a:t>•  Olagunju Temitope</a:t>
+            </a:r>
+          </a:p>
+          <a:p>
+            <a:pPr>
+              <a:spcBef>
+                <a:spcPts val="500"/>
+              </a:spcBef>
+              <a:defRPr sz="1150">
+                <a:solidFill>
+                  <a:srgbClr val="CBD5E1"/>
+                </a:solidFill>
+              </a:defRPr>
+            </a:pPr>
+            <a:r>
+              <a:t>•  Role: Full-Stack &amp; Cloud Infrastructure Engineer</a:t>
+            </a:r>
+          </a:p>
+          <a:p>
+            <a:pPr>
+              <a:spcBef>
+                <a:spcPts val="500"/>
+              </a:spcBef>
+              <a:defRPr sz="1150">
+                <a:solidFill>
+                  <a:srgbClr val="CBD5E1"/>
+                </a:solidFill>
+              </a:defRPr>
+            </a:pPr>
+            <a:r>
+              <a:t>•  Engineered: High-availability FastAPI backend, cryptographic governance ledger, institutional React 19 UI, and production containerization on Railway &amp; Netlify.</a:t>
+            </a:r>
+          </a:p>
+        </p:txBody>
+      </p:sp>
+      <p:sp>
+        <p:nvSpPr>
+          <p:cNvPr id="7" name="Rounded Rectangle 6"/>
+          <p:cNvSpPr/>
+          <p:nvPr/>
+        </p:nvSpPr>
+        <p:spPr>
+          <a:xfrm>
+            <a:off x="6217920" y="1645920"/>
+            <a:ext cx="5120640" cy="4389120"/>
+          </a:xfrm>
+          <a:prstGeom prst="roundRect">
+            <a:avLst/>
+          </a:prstGeom>
+          <a:solidFill>
+            <a:srgbClr val="12192D"/>
+          </a:solidFill>
+          <a:ln w="19050">
+            <a:solidFill>
+              <a:srgbClr val="3B82F6"/>
+            </a:solidFill>
+          </a:ln>
+        </p:spPr>
+        <p:style>
+          <a:lnRef idx="1">
+            <a:schemeClr val="accent1"/>
+          </a:lnRef>
+          <a:fillRef idx="3">
+            <a:schemeClr val="accent1"/>
+          </a:fillRef>
+          <a:effectRef idx="2">
+            <a:schemeClr val="accent1"/>
+          </a:effectRef>
+          <a:fontRef idx="minor">
+            <a:schemeClr val="lt1"/>
+          </a:fontRef>
+        </p:style>
+        <p:txBody>
+          <a:bodyPr rtlCol="0" anchor="ctr"/>
+          <a:lstStyle/>
+          <a:p>
+            <a:pPr algn="ctr"/>
+          </a:p>
+        </p:txBody>
+      </p:sp>
+      <p:sp>
+        <p:nvSpPr>
+          <p:cNvPr id="8" name="TextBox 7"/>
+          <p:cNvSpPr txBox="1"/>
+          <p:nvPr/>
+        </p:nvSpPr>
+        <p:spPr>
+          <a:xfrm>
+            <a:off x="6400800" y="1783080"/>
+            <a:ext cx="4754880" cy="4114800"/>
+          </a:xfrm>
+          <a:prstGeom prst="rect">
+            <a:avLst/>
+          </a:prstGeom>
+          <a:noFill/>
+        </p:spPr>
+        <p:txBody>
+          <a:bodyPr wrap="square">
+            <a:spAutoFit/>
+          </a:bodyPr>
+          <a:lstStyle/>
+          <a:p>
+            <a:pPr>
+              <a:defRPr sz="1500" b="1">
+                <a:solidFill>
+                  <a:srgbClr val="FFFFFF"/>
+                </a:solidFill>
+              </a:defRPr>
+            </a:pPr>
+            <a:r>
+              <a:t>Enterprise Technology Stack</a:t>
+            </a:r>
+          </a:p>
+          <a:p>
+            <a:pPr>
+              <a:defRPr sz="1000" b="1">
+                <a:solidFill>
+                  <a:srgbClr val="3B82F6"/>
+                </a:solidFill>
+              </a:defRPr>
+            </a:pPr>
+            <a:r>
+              <a:t>Modular Architecture</a:t>
+            </a:r>
+          </a:p>
+          <a:p>
+            <a:pPr>
+              <a:spcBef>
+                <a:spcPts val="500"/>
+              </a:spcBef>
+              <a:defRPr sz="1150">
+                <a:solidFill>
+                  <a:srgbClr val="CBD5E1"/>
+                </a:solidFill>
+              </a:defRPr>
+            </a:pPr>
+            <a:r>
+              <a:t>•  Frontend Architecture:</a:t>
+            </a:r>
+          </a:p>
+          <a:p>
+            <a:pPr>
+              <a:spcBef>
+                <a:spcPts val="500"/>
+              </a:spcBef>
+              <a:defRPr sz="1150">
+                <a:solidFill>
+                  <a:srgbClr val="CBD5E1"/>
+                </a:solidFill>
+              </a:defRPr>
+            </a:pPr>
+            <a:r>
+              <a:t>•  React 19, TypeScript, Vite, Tailwind CSS, Lucide Icons, Recharts financial data visualization.</a:t>
+            </a:r>
+          </a:p>
+          <a:p>
+            <a:pPr>
+              <a:spcBef>
+                <a:spcPts val="500"/>
+              </a:spcBef>
+              <a:defRPr sz="1150">
+                <a:solidFill>
+                  <a:srgbClr val="CBD5E1"/>
+                </a:solidFill>
+              </a:defRPr>
+            </a:pPr>
+            <a:r>
+              <a:t>•  Backend &amp; Microservices:</a:t>
+            </a:r>
+          </a:p>
+          <a:p>
+            <a:pPr>
+              <a:spcBef>
+                <a:spcPts val="500"/>
+              </a:spcBef>
+              <a:defRPr sz="1150">
+                <a:solidFill>
+                  <a:srgbClr val="CBD5E1"/>
+                </a:solidFill>
+              </a:defRPr>
+            </a:pPr>
+            <a:r>
+              <a:t>•  Python 3.11, FastAPI, Uvicorn ASGI server, Pydantic schemas, python-docx, python-pptx, ReportLab.</a:t>
+            </a:r>
+          </a:p>
+          <a:p>
+            <a:pPr>
+              <a:spcBef>
+                <a:spcPts val="500"/>
+              </a:spcBef>
+              <a:defRPr sz="1150">
+                <a:solidFill>
+                  <a:srgbClr val="CBD5E1"/>
+                </a:solidFill>
+              </a:defRPr>
+            </a:pPr>
+            <a:r>
+              <a:t>•  AI &amp; Analytical Inference:</a:t>
+            </a:r>
+          </a:p>
+          <a:p>
+            <a:pPr>
+              <a:spcBef>
+                <a:spcPts val="500"/>
+              </a:spcBef>
+              <a:defRPr sz="1150">
+                <a:solidFill>
+                  <a:srgbClr val="CBD5E1"/>
+                </a:solidFill>
+              </a:defRPr>
+            </a:pPr>
+            <a:r>
+              <a:t>•  Google Gemini 2.5 Flash / Pro (multi-modal reasoning, unscripted document analysis, automated CAM synthesis).</a:t>
+            </a:r>
+          </a:p>
+          <a:p>
+            <a:pPr>
+              <a:spcBef>
+                <a:spcPts val="500"/>
+              </a:spcBef>
+              <a:defRPr sz="1150">
+                <a:solidFill>
+                  <a:srgbClr val="CBD5E1"/>
+                </a:solidFill>
+              </a:defRPr>
+            </a:pPr>
+            <a:r>
+              <a:t>•  Cloud &amp; Deployment Infrastructure:</a:t>
+            </a:r>
+          </a:p>
+          <a:p>
+            <a:pPr>
+              <a:spcBef>
+                <a:spcPts val="500"/>
+              </a:spcBef>
+              <a:defRPr sz="1150">
+                <a:solidFill>
+                  <a:srgbClr val="CBD5E1"/>
+                </a:solidFill>
+              </a:defRPr>
+            </a:pPr>
+            <a:r>
+              <a:t>•  Railway (Containerized Python API), Netlify (Global CDN Edge Web Hosting), Git / GitHub.</a:t>
+            </a:r>
+          </a:p>
+        </p:txBody>
+      </p:sp>
+    </p:spTree>
+  </p:cSld>
+  <p:clrMapOvr>
+    <a:masterClrMapping/>
+  </p:clrMapOvr>
+</p:sld>
+</file>
+
+<file path=ppt/slides/slide13.xml><?xml version="1.0" encoding="utf-8"?>
+<p:sld xmlns:a="http://schemas.openxmlformats.org/drawingml/2006/main" xmlns:p="http://schemas.openxmlformats.org/presentationml/2006/main" xmlns:r="http://schemas.openxmlformats.org/officeDocument/2006/relationships">
+  <p:cSld>
+    <p:spTree>
+      <p:nvGrpSpPr>
+        <p:cNvPr id="1" name=""/>
+        <p:cNvGrpSpPr/>
+        <p:nvPr/>
+      </p:nvGrpSpPr>
+      <p:grpSpPr/>
+      <p:sp>
+        <p:nvSpPr>
+          <p:cNvPr id="2" name="Rectangle 1"/>
+          <p:cNvSpPr/>
+          <p:nvPr/>
+        </p:nvSpPr>
+        <p:spPr>
+          <a:xfrm>
+            <a:off x="0" y="0"/>
+            <a:ext cx="12191695" cy="6858000"/>
+          </a:xfrm>
+          <a:prstGeom prst="rect">
+            <a:avLst/>
+          </a:prstGeom>
+          <a:solidFill>
+            <a:srgbClr val="0B0F19"/>
+          </a:solidFill>
+          <a:ln>
+            <a:noFill/>
+          </a:ln>
+        </p:spPr>
+        <p:style>
+          <a:lnRef idx="1">
+            <a:schemeClr val="accent1"/>
+          </a:lnRef>
+          <a:fillRef idx="3">
+            <a:schemeClr val="accent1"/>
+          </a:fillRef>
+          <a:effectRef idx="2">
+            <a:schemeClr val="accent1"/>
+          </a:effectRef>
+          <a:fontRef idx="minor">
+            <a:schemeClr val="lt1"/>
+          </a:fontRef>
+        </p:style>
+        <p:txBody>
+          <a:bodyPr rtlCol="0" anchor="ctr"/>
+          <a:lstStyle/>
+          <a:p>
+            <a:pPr algn="ctr"/>
+          </a:p>
+        </p:txBody>
+      </p:sp>
+      <p:sp>
+        <p:nvSpPr>
+          <p:cNvPr id="3" name="TextBox 2"/>
+          <p:cNvSpPr txBox="1"/>
+          <p:nvPr/>
+        </p:nvSpPr>
+        <p:spPr>
+          <a:xfrm>
+            <a:off x="731520" y="365760"/>
+            <a:ext cx="10058400" cy="365760"/>
+          </a:xfrm>
+          <a:prstGeom prst="rect">
+            <a:avLst/>
+          </a:prstGeom>
+          <a:noFill/>
+        </p:spPr>
+        <p:txBody>
+          <a:bodyPr wrap="square">
+            <a:spAutoFit/>
+          </a:bodyPr>
+          <a:lstStyle/>
+          <a:p>
+            <a:pPr>
+              <a:defRPr sz="1100" b="1">
+                <a:solidFill>
+                  <a:srgbClr val="3B82F6"/>
+                </a:solidFill>
+              </a:defRPr>
+            </a:pPr>
+            <a:r>
+              <a:t>WARBA BANK CORPORATE BANKING · TRACK 1</a:t>
+            </a:r>
+          </a:p>
+        </p:txBody>
+      </p:sp>
+      <p:sp>
+        <p:nvSpPr>
+          <p:cNvPr id="4" name="TextBox 3"/>
+          <p:cNvSpPr txBox="1"/>
+          <p:nvPr/>
+        </p:nvSpPr>
+        <p:spPr>
+          <a:xfrm>
+            <a:off x="731520" y="685800"/>
+            <a:ext cx="10515600" cy="731520"/>
+          </a:xfrm>
+          <a:prstGeom prst="rect">
+            <a:avLst/>
+          </a:prstGeom>
+          <a:noFill/>
+        </p:spPr>
+        <p:txBody>
+          <a:bodyPr wrap="square">
+            <a:spAutoFit/>
+          </a:bodyPr>
+          <a:lstStyle/>
+          <a:p>
+            <a:pPr>
+              <a:defRPr sz="2200" b="1">
+                <a:solidFill>
+                  <a:srgbClr val="FFFFFF"/>
+                </a:solidFill>
+              </a:defRPr>
+            </a:pPr>
+            <a:r>
+              <a:t>Production Readiness: Live Demo &amp; 60-Second Evaluation Protocol</a:t>
+            </a:r>
+          </a:p>
+        </p:txBody>
+      </p:sp>
+      <p:sp>
+        <p:nvSpPr>
+          <p:cNvPr id="5" name="Rounded Rectangle 4"/>
+          <p:cNvSpPr/>
+          <p:nvPr/>
+        </p:nvSpPr>
+        <p:spPr>
+          <a:xfrm>
+            <a:off x="731520" y="1645920"/>
+            <a:ext cx="10607040" cy="4389120"/>
+          </a:xfrm>
+          <a:prstGeom prst="roundRect">
+            <a:avLst/>
+          </a:prstGeom>
+          <a:solidFill>
+            <a:srgbClr val="12192D"/>
+          </a:solidFill>
+          <a:ln w="19050">
+            <a:solidFill>
+              <a:srgbClr val="10B981"/>
+            </a:solidFill>
+          </a:ln>
+        </p:spPr>
+        <p:style>
+          <a:lnRef idx="1">
+            <a:schemeClr val="accent1"/>
+          </a:lnRef>
+          <a:fillRef idx="3">
+            <a:schemeClr val="accent1"/>
+          </a:fillRef>
+          <a:effectRef idx="2">
+            <a:schemeClr val="accent1"/>
+          </a:effectRef>
+          <a:fontRef idx="minor">
+            <a:schemeClr val="lt1"/>
+          </a:fontRef>
+        </p:style>
+        <p:txBody>
+          <a:bodyPr rtlCol="0" anchor="ctr"/>
+          <a:lstStyle/>
+          <a:p>
+            <a:pPr algn="ctr"/>
+          </a:p>
+        </p:txBody>
+      </p:sp>
+      <p:sp>
+        <p:nvSpPr>
+          <p:cNvPr id="6" name="TextBox 5"/>
+          <p:cNvSpPr txBox="1"/>
+          <p:nvPr/>
+        </p:nvSpPr>
+        <p:spPr>
+          <a:xfrm>
+            <a:off x="914400" y="1783080"/>
+            <a:ext cx="10241280" cy="4114800"/>
+          </a:xfrm>
+          <a:prstGeom prst="rect">
+            <a:avLst/>
+          </a:prstGeom>
+          <a:noFill/>
+        </p:spPr>
+        <p:txBody>
+          <a:bodyPr wrap="square">
+            <a:spAutoFit/>
+          </a:bodyPr>
+          <a:lstStyle/>
+          <a:p>
+            <a:pPr>
+              <a:defRPr sz="1500" b="1">
+                <a:solidFill>
+                  <a:srgbClr val="FFFFFF"/>
+                </a:solidFill>
+              </a:defRPr>
+            </a:pPr>
+            <a:r>
               <a:t>Test the Live Production Application Directly</a:t>
             </a:r>
           </a:p>
@@ -4600,6 +5167,21 @@
             </a:pPr>
             <a:r>
               <a:t>•  📂 GitHub Code Repository: https://github.com/anajimdeen01-debug/sanad-frontend</a:t>
+            </a:r>
+          </a:p>
+          <a:p>
+            <a:pPr>
+              <a:spcBef>
+                <a:spcPts val="500"/>
+              </a:spcBef>
+              <a:defRPr sz="1150">
+                <a:solidFill>
+                  <a:srgbClr val="CBD5E1"/>
+                </a:solidFill>
+              </a:defRPr>
+            </a:pPr>
+            <a:r>
+              <a:t>•  👥 Engineering Team: Najimdeen Adam Oyeyemi &amp; Olagunju Temitope</a:t>
             </a:r>
           </a:p>
           <a:p>

</xml_diff>